<commit_message>
diagam warstw w prezce
</commit_message>
<xml_diff>
--- a/Przeglad_koncowy_notes_ai.pptx
+++ b/Przeglad_koncowy_notes_ai.pptx
@@ -171,6 +171,11 @@
       </a:defRPr>
     </a:lvl9pPr>
   </p:defaultTextStyle>
+  <p:extLst>
+    <p:ext uri="{EFAFB233-063F-42B5-8137-9DF3F51BA10A}">
+      <p15:sldGuideLst xmlns:p15="http://schemas.microsoft.com/office/powerpoint/2012/main"/>
+    </p:ext>
+  </p:extLst>
 </p:presentation>
 </file>
 
@@ -45870,7 +45875,7 @@
 </file>
 
 <file path=ppt/slides/slide59.xml><?xml version="1.0" encoding="utf-8"?>
-<p:sld xmlns:a="http://schemas.openxmlformats.org/drawingml/2006/main" xmlns:r="http://schemas.openxmlformats.org/officeDocument/2006/relationships" xmlns:p="http://schemas.openxmlformats.org/presentationml/2006/main">
+<p:sld xmlns:a="http://schemas.openxmlformats.org/drawingml/2006/main" xmlns:r="http://schemas.openxmlformats.org/officeDocument/2006/relationships" xmlns:p="http://schemas.openxmlformats.org/presentationml/2006/main" show="0">
   <p:cSld>
     <p:spTree>
       <p:nvGrpSpPr>
@@ -47223,7 +47228,7 @@
               </a:tabLst>
             </a:pPr>
             <a:r>
-              <a:rPr lang="pl-PL" sz="2400" b="0" u="none" strike="noStrike">
+              <a:rPr lang="pl-PL" sz="2400" b="0" u="none" strike="noStrike" dirty="0">
                 <a:solidFill>
                   <a:schemeClr val="accent2">
                     <a:lumMod val="75000"/>
@@ -47233,9 +47238,9 @@
                 <a:uFillTx/>
                 <a:latin typeface="Calibri"/>
               </a:rPr>
-              <a:t>Diagram pakietów: model warstw systemu</a:t>
+              <a:t>Diagram pakietów: model warstw systemu, każda warstwa podzielona zgodnie z modelem obszarów systemu</a:t>
             </a:r>
-            <a:endParaRPr lang="en-US" sz="2400" b="0" u="none" strike="noStrike">
+            <a:endParaRPr lang="en-US" sz="2400" b="0" u="none" strike="noStrike" dirty="0">
               <a:solidFill>
                 <a:schemeClr val="dk1"/>
               </a:solidFill>
@@ -47246,6 +47251,36 @@
           </a:p>
         </p:txBody>
       </p:sp>
+      <p:pic>
+        <p:nvPicPr>
+          <p:cNvPr id="3" name="Picture 2">
+            <a:extLst>
+              <a:ext uri="{FF2B5EF4-FFF2-40B4-BE49-F238E27FC236}">
+                <a16:creationId xmlns:a16="http://schemas.microsoft.com/office/drawing/2014/main" id="{8422A43D-138C-4144-F3FB-DD974D6447DC}"/>
+              </a:ext>
+            </a:extLst>
+          </p:cNvPr>
+          <p:cNvPicPr>
+            <a:picLocks noChangeAspect="1"/>
+          </p:cNvPicPr>
+          <p:nvPr/>
+        </p:nvPicPr>
+        <p:blipFill>
+          <a:blip r:embed="rId2"/>
+          <a:stretch>
+            <a:fillRect/>
+          </a:stretch>
+        </p:blipFill>
+        <p:spPr>
+          <a:xfrm>
+            <a:off x="2397013" y="1866819"/>
+            <a:ext cx="4349974" cy="3124361"/>
+          </a:xfrm>
+          <a:prstGeom prst="rect">
+            <a:avLst/>
+          </a:prstGeom>
+        </p:spPr>
+      </p:pic>
     </p:spTree>
   </p:cSld>
   <p:clrMapOvr>

</xml_diff>